<commit_message>
Lock submission artefacts: BITS Pilani on slide 1, PDF export, catalogue 503, finale runcard.
</commit_message>
<xml_diff>
--- a/04_Documents/PRAHARI_Solution.pptx
+++ b/04_Documents/PRAHARI_Solution.pptx
@@ -1960,6 +1960,10 @@
             <a:prstDash val="solid"/>
           </a:ln>
         </p:spPr>
+        <p:txBody>
+          <a:bodyPr/>
+          <a:p/>
+        </p:txBody>
       </p:sp>
       <p:sp>
         <p:nvSpPr>
@@ -1985,6 +1989,10 @@
             <a:prstDash val="solid"/>
           </a:ln>
         </p:spPr>
+        <p:txBody>
+          <a:bodyPr/>
+          <a:p/>
+        </p:txBody>
       </p:sp>
       <p:sp>
         <p:nvSpPr>
@@ -2192,7 +2200,7 @@
                 <a:ea typeface="Calibri" pitchFamily="34" charset="-122"/>
                 <a:cs typeface="Calibri" pitchFamily="34" charset="-120"/>
               </a:rPr>
-              <a:t>Student category  ·  Team: Lead + Arnav + Aria  ·  Submission 07 Sep 2026</a:t>
+              <a:t>Student category  ·  BITS Pilani  ·  Team: Lead + Arnav + Aria  ·  Submission 07 Sep 2026</a:t>
             </a:r>
             <a:endParaRPr lang="en-US" sz="1300" dirty="0"/>
           </a:p>
@@ -2222,6 +2230,10 @@
             <a:prstDash val="solid"/>
           </a:ln>
         </p:spPr>
+        <p:txBody>
+          <a:bodyPr/>
+          <a:p/>
+        </p:txBody>
       </p:sp>
       <p:sp>
         <p:nvSpPr>

</xml_diff>